<commit_message>
Confirmations within 100 m; "My addresses" filter; new colors
</commit_message>
<xml_diff>
--- a/docs/WorkInProgress-Pitch.pptx
+++ b/docs/WorkInProgress-Pitch.pptx
@@ -1105,7 +1105,7 @@
           </a:p>
           <a:p>
             <a:r>
-              <a:t>"Two sources, one set of rules. Official data comes in automatically from four providers, every hour, placed on the real streets. A citizen report appears right away with a dotted outline, marked Unconfirmed, so neighbours can check it. Signed-in users who walk within 50 metres are asked: do you have this problem too? Anyone can also answer on the event page. Three 'yes' answers from people within a kilometre make it Confirmed. If at least three people answer 'no, mine works' and they outnumber the 'yes' answers, the report is Disputed and comes off the map. So false alarms and pranks correct themselves, without moderators. Old reports expire on their own."</a:t>
+              <a:t>"Two sources, one set of rules. Official data comes in automatically from four providers, every hour, placed on the real streets. A citizen report appears right away with a dotted outline, marked Unconfirmed, so neighbours can check it. Signed-in users who walk within 50 metres are asked: do you have this problem too? Anyone can also answer on the event page. Three 'yes' answers from people within 100 metres make it Confirmed. If at least three people answer 'no, mine works' and they outnumber the 'yes' answers, the report is Disputed and comes off the map. So false alarms and pranks correct themselves, without moderators. Old reports expire on their own."</a:t>
             </a:r>
           </a:p>
           <a:p>
@@ -1530,7 +1530,7 @@
           </a:p>
           <a:p>
             <a:r>
-              <a:t>"First, the official side. Four providers publish their cuts on their own websites. Every hour our importers read them, place every address on the real streets and put it on the map: blue when it's a full cut, yellow when only some buildings or low pressure. When a notice disappears from the provider's site, we mark it resolved."</a:t>
+              <a:t>"First, the official side. Four providers publish their cuts on their own websites. Every hour our importers read them, place every address on the real streets and put it on the map: red when it's a full cut, yellow when only some buildings are hit or the pressure is low. When a notice disappears from the provider's site, we mark it resolved."</a:t>
             </a:r>
           </a:p>
           <a:p>
@@ -1610,7 +1610,7 @@
           </a:p>
           <a:p>
             <a:r>
-              <a:t>"Second, what residents report, from the web app or from Telegram. A new report shows up grey and dotted: unconfirmed. Signed-in users who walk within 50 metres are asked: do you have this problem too? Anyone can also answer on the event page. Three 'yes' answers make it Confirmed, green. If at least three people say 'mine works' and they're the majority, it's Disputed and comes off the map. So false alarms correct themselves, without moderators."</a:t>
+              <a:t>"Second, what residents report, from the web app or from Telegram. A new report shows up in the same red or yellow, but with diagonal stripes, so you always know it came from residents, and a dotted outline while it's unconfirmed. Signed-in users who walk within 50 metres are asked: do you have this problem too? Anyone can also answer on the event page. Three 'yes' answers make it Confirmed. If at least three people say 'mine works' and they're the majority, it's Disputed and comes off the map. So false alarms correct themselves, without moderators."</a:t>
             </a:r>
           </a:p>
         </p:txBody>
@@ -5093,7 +5093,7 @@
         <p:spPr>
           <a:xfrm>
             <a:off x="6949440" y="5120640"/>
-            <a:ext cx="1024128" cy="292608"/>
+            <a:ext cx="1234440" cy="292608"/>
           </a:xfrm>
           <a:prstGeom prst="roundRect">
             <a:avLst>
@@ -5101,11 +5101,11 @@
             </a:avLst>
           </a:prstGeom>
           <a:solidFill>
-            <a:srgbClr val="1C2940"/>
+            <a:srgbClr val="3A1F1C"/>
           </a:solidFill>
           <a:ln w="12700">
             <a:solidFill>
-              <a:srgbClr val="7AA7FF"/>
+              <a:srgbClr val="FF7A6B"/>
             </a:solidFill>
           </a:ln>
           <a:effectLst/>
@@ -5147,7 +5147,7 @@
             <a:avLst/>
           </a:prstGeom>
           <a:solidFill>
-            <a:srgbClr val="7AA7FF"/>
+            <a:srgbClr val="FF7A6B"/>
           </a:solidFill>
           <a:ln>
             <a:noFill/>
@@ -5185,7 +5185,7 @@
         <p:spPr>
           <a:xfrm>
             <a:off x="7278624" y="5120640"/>
-            <a:ext cx="658368" cy="292608"/>
+            <a:ext cx="868680" cy="292608"/>
           </a:xfrm>
           <a:prstGeom prst="rect">
             <a:avLst/>
@@ -5206,11 +5206,11 @@
             <a:r>
               <a:rPr sz="950" b="1">
                 <a:solidFill>
-                  <a:srgbClr val="7AA7FF"/>
-                </a:solidFill>
-                <a:latin typeface="Arial"/>
-              </a:rPr>
-              <a:t>Official</a:t>
+                  <a:srgbClr val="FF7A6B"/>
+                </a:solidFill>
+                <a:latin typeface="Arial"/>
+              </a:rPr>
+              <a:t>Full outage</a:t>
             </a:r>
           </a:p>
         </p:txBody>
@@ -5223,139 +5223,8 @@
         </p:nvSpPr>
         <p:spPr>
           <a:xfrm>
-            <a:off x="8037575" y="5120640"/>
-            <a:ext cx="1024128" cy="292608"/>
-          </a:xfrm>
-          <a:prstGeom prst="roundRect">
-            <a:avLst>
-              <a:gd name="adj" fmla="val 50000"/>
-            </a:avLst>
-          </a:prstGeom>
-          <a:solidFill>
-            <a:srgbClr val="16301F"/>
-          </a:solidFill>
-          <a:ln w="12700">
-            <a:solidFill>
-              <a:srgbClr val="5CC98A"/>
-            </a:solidFill>
-          </a:ln>
-          <a:effectLst/>
-        </p:spPr>
-        <p:style>
-          <a:lnRef idx="1">
-            <a:schemeClr val="accent1"/>
-          </a:lnRef>
-          <a:fillRef idx="3">
-            <a:schemeClr val="accent1"/>
-          </a:fillRef>
-          <a:effectRef idx="2">
-            <a:schemeClr val="accent1"/>
-          </a:effectRef>
-          <a:fontRef idx="minor">
-            <a:schemeClr val="lt1"/>
-          </a:fontRef>
-        </p:style>
-        <p:txBody>
-          <a:bodyPr rtlCol="0" anchor="ctr"/>
-          <a:lstStyle/>
-          <a:p>
-            <a:pPr algn="ctr"/>
-          </a:p>
-        </p:txBody>
-      </p:sp>
-      <p:sp>
-        <p:nvSpPr>
-          <p:cNvPr id="11" name="Oval 10"/>
-          <p:cNvSpPr/>
-          <p:nvPr/>
-        </p:nvSpPr>
-        <p:spPr>
-          <a:xfrm>
-            <a:off x="8183879" y="5212080"/>
-            <a:ext cx="109728" cy="109728"/>
-          </a:xfrm>
-          <a:prstGeom prst="ellipse">
-            <a:avLst/>
-          </a:prstGeom>
-          <a:solidFill>
-            <a:srgbClr val="5CC98A"/>
-          </a:solidFill>
-          <a:ln>
-            <a:noFill/>
-          </a:ln>
-          <a:effectLst/>
-        </p:spPr>
-        <p:style>
-          <a:lnRef idx="1">
-            <a:schemeClr val="accent1"/>
-          </a:lnRef>
-          <a:fillRef idx="3">
-            <a:schemeClr val="accent1"/>
-          </a:fillRef>
-          <a:effectRef idx="2">
-            <a:schemeClr val="accent1"/>
-          </a:effectRef>
-          <a:fontRef idx="minor">
-            <a:schemeClr val="lt1"/>
-          </a:fontRef>
-        </p:style>
-        <p:txBody>
-          <a:bodyPr rtlCol="0" anchor="ctr"/>
-          <a:lstStyle/>
-          <a:p>
-            <a:pPr algn="ctr"/>
-          </a:p>
-        </p:txBody>
-      </p:sp>
-      <p:sp>
-        <p:nvSpPr>
-          <p:cNvPr id="12" name="TextBox 11"/>
-          <p:cNvSpPr txBox="1"/>
-          <p:nvPr/>
-        </p:nvSpPr>
-        <p:spPr>
-          <a:xfrm>
-            <a:off x="8366759" y="5120640"/>
-            <a:ext cx="658368" cy="292608"/>
-          </a:xfrm>
-          <a:prstGeom prst="rect">
-            <a:avLst/>
-          </a:prstGeom>
-          <a:noFill/>
-        </p:spPr>
-        <p:txBody>
-          <a:bodyPr wrap="square" lIns="0" rIns="0" tIns="0" bIns="0" anchor="ctr">
-            <a:spAutoFit/>
-          </a:bodyPr>
-          <a:lstStyle/>
-          <a:p>
-            <a:pPr algn="l">
-              <a:spcAft>
-                <a:spcPts val="0"/>
-              </a:spcAft>
-            </a:pPr>
-            <a:r>
-              <a:rPr sz="950" b="1">
-                <a:solidFill>
-                  <a:srgbClr val="5CC98A"/>
-                </a:solidFill>
-                <a:latin typeface="Arial"/>
-              </a:rPr>
-              <a:t>Confirmed</a:t>
-            </a:r>
-          </a:p>
-        </p:txBody>
-      </p:sp>
-      <p:sp>
-        <p:nvSpPr>
-          <p:cNvPr id="13" name="Rounded Rectangle 12"/>
-          <p:cNvSpPr/>
-          <p:nvPr/>
-        </p:nvSpPr>
-        <p:spPr>
-          <a:xfrm>
-            <a:off x="9125712" y="5120640"/>
-            <a:ext cx="1024128" cy="292608"/>
+            <a:off x="8257031" y="5120640"/>
+            <a:ext cx="914400" cy="292608"/>
           </a:xfrm>
           <a:prstGeom prst="roundRect">
             <a:avLst>
@@ -5396,13 +5265,13 @@
       </p:sp>
       <p:sp>
         <p:nvSpPr>
-          <p:cNvPr id="14" name="Oval 13"/>
+          <p:cNvPr id="11" name="Oval 10"/>
           <p:cNvSpPr/>
           <p:nvPr/>
         </p:nvSpPr>
         <p:spPr>
           <a:xfrm>
-            <a:off x="9272016" y="5212080"/>
+            <a:off x="8403336" y="5212080"/>
             <a:ext cx="109728" cy="109728"/>
           </a:xfrm>
           <a:prstGeom prst="ellipse">
@@ -5440,14 +5309,14 @@
       </p:sp>
       <p:sp>
         <p:nvSpPr>
-          <p:cNvPr id="15" name="TextBox 14"/>
+          <p:cNvPr id="12" name="TextBox 11"/>
           <p:cNvSpPr txBox="1"/>
           <p:nvPr/>
         </p:nvSpPr>
         <p:spPr>
           <a:xfrm>
-            <a:off x="9454896" y="5120640"/>
-            <a:ext cx="658368" cy="292608"/>
+            <a:off x="8586215" y="5120640"/>
+            <a:ext cx="548640" cy="292608"/>
           </a:xfrm>
           <a:prstGeom prst="rect">
             <a:avLst/>
@@ -5473,6 +5342,144 @@
                 <a:latin typeface="Arial"/>
               </a:rPr>
               <a:t>Partial</a:t>
+            </a:r>
+          </a:p>
+        </p:txBody>
+      </p:sp>
+      <p:sp>
+        <p:nvSpPr>
+          <p:cNvPr id="13" name="Rounded Rectangle 12"/>
+          <p:cNvSpPr/>
+          <p:nvPr/>
+        </p:nvSpPr>
+        <p:spPr>
+          <a:xfrm>
+            <a:off x="9244584" y="5120640"/>
+            <a:ext cx="1600200" cy="292608"/>
+          </a:xfrm>
+          <a:prstGeom prst="roundRect">
+            <a:avLst>
+              <a:gd name="adj" fmla="val 50000"/>
+            </a:avLst>
+          </a:prstGeom>
+          <a:solidFill>
+            <a:srgbClr val="1F242B"/>
+          </a:solidFill>
+          <a:ln w="12700">
+            <a:solidFill>
+              <a:srgbClr val="A9B0B9"/>
+            </a:solidFill>
+          </a:ln>
+          <a:effectLst/>
+        </p:spPr>
+        <p:style>
+          <a:lnRef idx="1">
+            <a:schemeClr val="accent1"/>
+          </a:lnRef>
+          <a:fillRef idx="3">
+            <a:schemeClr val="accent1"/>
+          </a:fillRef>
+          <a:effectRef idx="2">
+            <a:schemeClr val="accent1"/>
+          </a:effectRef>
+          <a:fontRef idx="minor">
+            <a:schemeClr val="lt1"/>
+          </a:fontRef>
+        </p:style>
+        <p:txBody>
+          <a:bodyPr rtlCol="0" anchor="ctr"/>
+          <a:lstStyle/>
+          <a:p>
+            <a:pPr algn="ctr"/>
+          </a:p>
+        </p:txBody>
+      </p:sp>
+      <p:sp>
+        <p:nvSpPr>
+          <p:cNvPr id="14" name="Oval 13"/>
+          <p:cNvSpPr/>
+          <p:nvPr/>
+        </p:nvSpPr>
+        <p:spPr>
+          <a:xfrm>
+            <a:off x="9354311" y="5184648"/>
+            <a:ext cx="164592" cy="164592"/>
+          </a:xfrm>
+          <a:prstGeom prst="ellipse">
+            <a:avLst/>
+          </a:prstGeom>
+          <a:pattFill prst="wdUpDiag">
+            <a:fgClr>
+              <a:srgbClr val="A9B0B9"/>
+            </a:fgClr>
+            <a:bgClr>
+              <a:srgbClr val="1F242B"/>
+            </a:bgClr>
+          </a:pattFill>
+          <a:ln w="9525">
+            <a:solidFill>
+              <a:srgbClr val="A9B0B9"/>
+            </a:solidFill>
+          </a:ln>
+          <a:effectLst/>
+        </p:spPr>
+        <p:style>
+          <a:lnRef idx="1">
+            <a:schemeClr val="accent1"/>
+          </a:lnRef>
+          <a:fillRef idx="3">
+            <a:schemeClr val="accent1"/>
+          </a:fillRef>
+          <a:effectRef idx="2">
+            <a:schemeClr val="accent1"/>
+          </a:effectRef>
+          <a:fontRef idx="minor">
+            <a:schemeClr val="lt1"/>
+          </a:fontRef>
+        </p:style>
+        <p:txBody>
+          <a:bodyPr rtlCol="0" anchor="ctr"/>
+          <a:lstStyle/>
+          <a:p>
+            <a:pPr algn="ctr"/>
+          </a:p>
+        </p:txBody>
+      </p:sp>
+      <p:sp>
+        <p:nvSpPr>
+          <p:cNvPr id="15" name="TextBox 14"/>
+          <p:cNvSpPr txBox="1"/>
+          <p:nvPr/>
+        </p:nvSpPr>
+        <p:spPr>
+          <a:xfrm>
+            <a:off x="9573767" y="5120640"/>
+            <a:ext cx="1234440" cy="292608"/>
+          </a:xfrm>
+          <a:prstGeom prst="rect">
+            <a:avLst/>
+          </a:prstGeom>
+          <a:noFill/>
+        </p:spPr>
+        <p:txBody>
+          <a:bodyPr wrap="square" lIns="0" rIns="0" tIns="0" bIns="0" anchor="ctr">
+            <a:spAutoFit/>
+          </a:bodyPr>
+          <a:lstStyle/>
+          <a:p>
+            <a:pPr algn="l">
+              <a:spcAft>
+                <a:spcPts val="0"/>
+              </a:spcAft>
+            </a:pPr>
+            <a:r>
+              <a:rPr sz="950" b="1">
+                <a:solidFill>
+                  <a:srgbClr val="A9B0B9"/>
+                </a:solidFill>
+                <a:latin typeface="Arial"/>
+              </a:rPr>
+              <a:t>Resident report</a:t>
             </a:r>
           </a:p>
         </p:txBody>
@@ -7758,7 +7765,7 @@
                 </a:solidFill>
                 <a:latin typeface="Arial"/>
               </a:rPr>
-              <a:t>A report needs an account, 3 "Me too" answers from people within 1 km, one answer per device, a Disputed status, and automatic expiry.</a:t>
+              <a:t>A report needs an account, 3 "Me too" answers from people within 100 m, one answer per device, a Disputed status, and automatic expiry.</a:t>
             </a:r>
           </a:p>
         </p:txBody>
@@ -11232,7 +11239,7 @@
             <a:avLst/>
           </a:prstGeom>
           <a:solidFill>
-            <a:srgbClr val="1F5FC9"/>
+            <a:srgbClr val="C0271D"/>
           </a:solidFill>
           <a:ln>
             <a:noFill/>
@@ -11295,7 +11302,7 @@
                 </a:solidFill>
                 <a:latin typeface="Arial"/>
               </a:rPr>
-              <a:t>Official</a:t>
+              <a:t>Full outage</a:t>
             </a:r>
           </a:p>
         </p:txBody>
@@ -11330,11 +11337,11 @@
             <a:r>
               <a:rPr sz="2200" b="1">
                 <a:solidFill>
-                  <a:srgbClr val="1F5FC9"/>
-                </a:solidFill>
-                <a:latin typeface="Arial"/>
-              </a:rPr>
-              <a:t>Blue</a:t>
+                  <a:srgbClr val="C0271D"/>
+                </a:solidFill>
+                <a:latin typeface="Arial"/>
+              </a:rPr>
+              <a:t>Red</a:t>
             </a:r>
           </a:p>
         </p:txBody>
@@ -11376,7 +11383,7 @@
                 </a:solidFill>
                 <a:latin typeface="Arial"/>
               </a:rPr>
-              <a:t>announced by the provider; on the map right away, source named</a:t>
+              <a:t>no water, power or gas at the addresses: official or reported</a:t>
             </a:r>
           </a:p>
         </p:txBody>
@@ -11444,7 +11451,7 @@
             <a:avLst/>
           </a:prstGeom>
           <a:solidFill>
-            <a:srgbClr val="1C7340"/>
+            <a:srgbClr val="A16207"/>
           </a:solidFill>
           <a:ln>
             <a:noFill/>
@@ -11507,7 +11514,7 @@
                 </a:solidFill>
                 <a:latin typeface="Arial"/>
               </a:rPr>
-              <a:t>Confirmed</a:t>
+              <a:t>Partial</a:t>
             </a:r>
           </a:p>
         </p:txBody>
@@ -11542,11 +11549,11 @@
             <a:r>
               <a:rPr sz="2200" b="1">
                 <a:solidFill>
-                  <a:srgbClr val="1C7340"/>
-                </a:solidFill>
-                <a:latin typeface="Arial"/>
-              </a:rPr>
-              <a:t>Green</a:t>
+                  <a:srgbClr val="A16207"/>
+                </a:solidFill>
+                <a:latin typeface="Arial"/>
+              </a:rPr>
+              <a:t>Yellow</a:t>
             </a:r>
           </a:p>
         </p:txBody>
@@ -11588,7 +11595,7 @@
                 </a:solidFill>
                 <a:latin typeface="Arial"/>
               </a:rPr>
-              <a:t>3 × "Me too" from people within 1 km. The app asks signed-in users within 50 m</a:t>
+              <a:t>only some buildings, or low pressure: you may be affected</a:t>
             </a:r>
           </a:p>
         </p:txBody>
@@ -11656,7 +11663,7 @@
             <a:avLst/>
           </a:prstGeom>
           <a:solidFill>
-            <a:srgbClr val="A16207"/>
+            <a:srgbClr val="555A61"/>
           </a:solidFill>
           <a:ln>
             <a:noFill/>
@@ -11719,7 +11726,7 @@
                 </a:solidFill>
                 <a:latin typeface="Arial"/>
               </a:rPr>
-              <a:t>Partial</a:t>
+              <a:t>Resident report</a:t>
             </a:r>
           </a:p>
         </p:txBody>
@@ -11754,11 +11761,11 @@
             <a:r>
               <a:rPr sz="2200" b="1">
                 <a:solidFill>
-                  <a:srgbClr val="A16207"/>
-                </a:solidFill>
-                <a:latin typeface="Arial"/>
-              </a:rPr>
-              <a:t>Yellow</a:t>
+                  <a:srgbClr val="16181B"/>
+                </a:solidFill>
+                <a:latin typeface="Arial"/>
+              </a:rPr>
+              <a:t>Stripes</a:t>
             </a:r>
           </a:p>
         </p:txBody>
@@ -11800,7 +11807,7 @@
                 </a:solidFill>
                 <a:latin typeface="Arial"/>
               </a:rPr>
-              <a:t>only some buildings, or low pressure: you may be affected</a:t>
+              <a:t>same colours, diagonal stripes. 3 × "Me too" within 100 m → Confirmed</a:t>
             </a:r>
           </a:p>
         </p:txBody>
@@ -16681,7 +16688,7 @@
                           </a:solidFill>
                           <a:latin typeface="Arial"/>
                         </a:rPr>
-                        <a:t>Within 1 km (GPS), one answer per device</a:t>
+                        <a:t>Within 100 m (GPS), one answer per device</a:t>
                       </a:r>
                     </a:p>
                   </a:txBody>
@@ -20966,7 +20973,7 @@
                 </a:solidFill>
                 <a:latin typeface="Arial"/>
               </a:rPr>
-              <a:t>23</a:t>
+              <a:t>40</a:t>
             </a:r>
           </a:p>
         </p:txBody>
@@ -21095,7 +21102,7 @@
                 </a:solidFill>
                 <a:latin typeface="Arial"/>
               </a:rPr>
-              <a:t>254</a:t>
+              <a:t>544</a:t>
             </a:r>
           </a:p>
         </p:txBody>
@@ -21224,7 +21231,7 @@
                 </a:solidFill>
                 <a:latin typeface="Arial"/>
               </a:rPr>
-              <a:t>56</a:t>
+              <a:t>63</a:t>
             </a:r>
           </a:p>
         </p:txBody>
@@ -21437,7 +21444,7 @@
                 </a:solidFill>
                 <a:latin typeface="Arial"/>
               </a:rPr>
-              <a:t>Live snapshot, 26 Sep 2026</a:t>
+              <a:t>Live snapshot, 27 Sep 2026</a:t>
             </a:r>
           </a:p>
         </p:txBody>
@@ -23418,11 +23425,11 @@
             </a:avLst>
           </a:prstGeom>
           <a:solidFill>
-            <a:srgbClr val="E7EEFA"/>
+            <a:srgbClr val="F3F3EF"/>
           </a:solidFill>
           <a:ln w="12700">
             <a:solidFill>
-              <a:srgbClr val="1F5FC9"/>
+              <a:srgbClr val="C4C4BB"/>
             </a:solidFill>
           </a:ln>
           <a:effectLst/>
@@ -23521,7 +23528,7 @@
             <a:r>
               <a:rPr sz="1250" b="1">
                 <a:solidFill>
-                  <a:srgbClr val="1F5FC9"/>
+                  <a:srgbClr val="16181B"/>
                 </a:solidFill>
                 <a:latin typeface="Arial"/>
               </a:rPr>
@@ -23558,7 +23565,7 @@
         <p:spPr>
           <a:xfrm>
             <a:off x="8375903" y="3401568"/>
-            <a:ext cx="1133856" cy="274320"/>
+            <a:ext cx="1481328" cy="274320"/>
           </a:xfrm>
           <a:prstGeom prst="roundRect">
             <a:avLst>
@@ -23566,11 +23573,11 @@
             </a:avLst>
           </a:prstGeom>
           <a:solidFill>
-            <a:srgbClr val="E7EEFA"/>
+            <a:srgbClr val="FBE9E7"/>
           </a:solidFill>
           <a:ln w="12700">
             <a:solidFill>
-              <a:srgbClr val="1F5FC9"/>
+              <a:srgbClr val="C0271D"/>
             </a:solidFill>
           </a:ln>
           <a:effectLst/>
@@ -23612,7 +23619,7 @@
             <a:avLst/>
           </a:prstGeom>
           <a:solidFill>
-            <a:srgbClr val="1F5FC9"/>
+            <a:srgbClr val="C0271D"/>
           </a:solidFill>
           <a:ln>
             <a:noFill/>
@@ -23650,7 +23657,7 @@
         <p:spPr>
           <a:xfrm>
             <a:off x="8705087" y="3401568"/>
-            <a:ext cx="768096" cy="274320"/>
+            <a:ext cx="1115568" cy="274320"/>
           </a:xfrm>
           <a:prstGeom prst="rect">
             <a:avLst/>
@@ -23671,11 +23678,11 @@
             <a:r>
               <a:rPr sz="900" b="1">
                 <a:solidFill>
-                  <a:srgbClr val="1F5FC9"/>
-                </a:solidFill>
-                <a:latin typeface="Arial"/>
-              </a:rPr>
-              <a:t>Official</a:t>
+                  <a:srgbClr val="C0271D"/>
+                </a:solidFill>
+                <a:latin typeface="Arial"/>
+              </a:rPr>
+              <a:t>Full outage · red</a:t>
             </a:r>
           </a:p>
         </p:txBody>
@@ -23688,8 +23695,8 @@
         </p:nvSpPr>
         <p:spPr>
           <a:xfrm>
-            <a:off x="9564624" y="3401568"/>
-            <a:ext cx="1133856" cy="274320"/>
+            <a:off x="9948672" y="3401568"/>
+            <a:ext cx="1481328" cy="274320"/>
           </a:xfrm>
           <a:prstGeom prst="roundRect">
             <a:avLst>
@@ -23736,7 +23743,7 @@
         </p:nvSpPr>
         <p:spPr>
           <a:xfrm>
-            <a:off x="9710928" y="3483864"/>
+            <a:off x="10094976" y="3483864"/>
             <a:ext cx="109728" cy="109728"/>
           </a:xfrm>
           <a:prstGeom prst="ellipse">
@@ -23780,8 +23787,8 @@
         </p:nvSpPr>
         <p:spPr>
           <a:xfrm>
-            <a:off x="9893807" y="3401568"/>
-            <a:ext cx="768096" cy="274320"/>
+            <a:off x="10277855" y="3401568"/>
+            <a:ext cx="1115568" cy="274320"/>
           </a:xfrm>
           <a:prstGeom prst="rect">
             <a:avLst/>
@@ -23806,7 +23813,7 @@
                 </a:solidFill>
                 <a:latin typeface="Arial"/>
               </a:rPr>
-              <a:t>Partial</a:t>
+              <a:t>Partial · yellow</a:t>
             </a:r>
           </a:p>
         </p:txBody>
@@ -24811,7 +24818,7 @@
                 </a:solidFill>
                 <a:latin typeface="Arial"/>
               </a:rPr>
-              <a:t>Signed-in users within 50 m are asked "Do you have this problem too?" Anyone can answer on the event page: one per device, within 1 km</a:t>
+              <a:t>Signed-in users within 50 m are asked "Do you have this problem too?" Anyone can answer on the event page: one per device, within 100 m</a:t>
             </a:r>
           </a:p>
         </p:txBody>
@@ -24869,11 +24876,11 @@
             </a:avLst>
           </a:prstGeom>
           <a:solidFill>
-            <a:srgbClr val="E3F3EA"/>
+            <a:srgbClr val="F3F3EF"/>
           </a:solidFill>
           <a:ln w="12700">
             <a:solidFill>
-              <a:srgbClr val="1C7340"/>
+              <a:srgbClr val="C4C4BB"/>
             </a:solidFill>
           </a:ln>
           <a:effectLst/>
@@ -24972,7 +24979,7 @@
             <a:r>
               <a:rPr sz="1250" b="1">
                 <a:solidFill>
-                  <a:srgbClr val="1C7340"/>
+                  <a:srgbClr val="16181B"/>
                 </a:solidFill>
                 <a:latin typeface="Arial"/>
               </a:rPr>
@@ -25009,7 +25016,145 @@
         <p:spPr>
           <a:xfrm>
             <a:off x="8375903" y="3401568"/>
-            <a:ext cx="1133856" cy="274320"/>
+            <a:ext cx="1481328" cy="274320"/>
+          </a:xfrm>
+          <a:prstGeom prst="roundRect">
+            <a:avLst>
+              <a:gd name="adj" fmla="val 50000"/>
+            </a:avLst>
+          </a:prstGeom>
+          <a:solidFill>
+            <a:srgbClr val="FBE9E7"/>
+          </a:solidFill>
+          <a:ln w="12700">
+            <a:solidFill>
+              <a:srgbClr val="C0271D"/>
+            </a:solidFill>
+          </a:ln>
+          <a:effectLst/>
+        </p:spPr>
+        <p:style>
+          <a:lnRef idx="1">
+            <a:schemeClr val="accent1"/>
+          </a:lnRef>
+          <a:fillRef idx="3">
+            <a:schemeClr val="accent1"/>
+          </a:fillRef>
+          <a:effectRef idx="2">
+            <a:schemeClr val="accent1"/>
+          </a:effectRef>
+          <a:fontRef idx="minor">
+            <a:schemeClr val="lt1"/>
+          </a:fontRef>
+        </p:style>
+        <p:txBody>
+          <a:bodyPr rtlCol="0" anchor="ctr"/>
+          <a:lstStyle/>
+          <a:p>
+            <a:pPr algn="ctr"/>
+          </a:p>
+        </p:txBody>
+      </p:sp>
+      <p:sp>
+        <p:nvSpPr>
+          <p:cNvPr id="16" name="Oval 15"/>
+          <p:cNvSpPr/>
+          <p:nvPr/>
+        </p:nvSpPr>
+        <p:spPr>
+          <a:xfrm>
+            <a:off x="8485631" y="3456432"/>
+            <a:ext cx="164592" cy="164592"/>
+          </a:xfrm>
+          <a:prstGeom prst="ellipse">
+            <a:avLst/>
+          </a:prstGeom>
+          <a:pattFill prst="wdUpDiag">
+            <a:fgClr>
+              <a:srgbClr val="C0271D"/>
+            </a:fgClr>
+            <a:bgClr>
+              <a:srgbClr val="FBE9E7"/>
+            </a:bgClr>
+          </a:pattFill>
+          <a:ln w="9525">
+            <a:solidFill>
+              <a:srgbClr val="C0271D"/>
+            </a:solidFill>
+          </a:ln>
+          <a:effectLst/>
+        </p:spPr>
+        <p:style>
+          <a:lnRef idx="1">
+            <a:schemeClr val="accent1"/>
+          </a:lnRef>
+          <a:fillRef idx="3">
+            <a:schemeClr val="accent1"/>
+          </a:fillRef>
+          <a:effectRef idx="2">
+            <a:schemeClr val="accent1"/>
+          </a:effectRef>
+          <a:fontRef idx="minor">
+            <a:schemeClr val="lt1"/>
+          </a:fontRef>
+        </p:style>
+        <p:txBody>
+          <a:bodyPr rtlCol="0" anchor="ctr"/>
+          <a:lstStyle/>
+          <a:p>
+            <a:pPr algn="ctr"/>
+          </a:p>
+        </p:txBody>
+      </p:sp>
+      <p:sp>
+        <p:nvSpPr>
+          <p:cNvPr id="17" name="TextBox 16"/>
+          <p:cNvSpPr txBox="1"/>
+          <p:nvPr/>
+        </p:nvSpPr>
+        <p:spPr>
+          <a:xfrm>
+            <a:off x="8705087" y="3401568"/>
+            <a:ext cx="1115568" cy="274320"/>
+          </a:xfrm>
+          <a:prstGeom prst="rect">
+            <a:avLst/>
+          </a:prstGeom>
+          <a:noFill/>
+        </p:spPr>
+        <p:txBody>
+          <a:bodyPr wrap="square" lIns="0" rIns="0" tIns="0" bIns="0" anchor="ctr">
+            <a:spAutoFit/>
+          </a:bodyPr>
+          <a:lstStyle/>
+          <a:p>
+            <a:pPr algn="l">
+              <a:spcAft>
+                <a:spcPts val="0"/>
+              </a:spcAft>
+            </a:pPr>
+            <a:r>
+              <a:rPr sz="900" b="1">
+                <a:solidFill>
+                  <a:srgbClr val="C0271D"/>
+                </a:solidFill>
+                <a:latin typeface="Arial"/>
+              </a:rPr>
+              <a:t>Same colours, striped</a:t>
+            </a:r>
+          </a:p>
+        </p:txBody>
+      </p:sp>
+      <p:sp>
+        <p:nvSpPr>
+          <p:cNvPr id="18" name="Rounded Rectangle 17"/>
+          <p:cNvSpPr/>
+          <p:nvPr/>
+        </p:nvSpPr>
+        <p:spPr>
+          <a:xfrm>
+            <a:off x="9948672" y="3401568"/>
+            <a:ext cx="1481328" cy="274320"/>
           </a:xfrm>
           <a:prstGeom prst="roundRect">
             <a:avLst>
@@ -25050,13 +25195,13 @@
       </p:sp>
       <p:sp>
         <p:nvSpPr>
-          <p:cNvPr id="16" name="Oval 15"/>
+          <p:cNvPr id="19" name="Oval 18"/>
           <p:cNvSpPr/>
           <p:nvPr/>
         </p:nvSpPr>
         <p:spPr>
           <a:xfrm>
-            <a:off x="8522207" y="3483864"/>
+            <a:off x="10094976" y="3483864"/>
             <a:ext cx="109728" cy="109728"/>
           </a:xfrm>
           <a:prstGeom prst="ellipse">
@@ -25094,14 +25239,14 @@
       </p:sp>
       <p:sp>
         <p:nvSpPr>
-          <p:cNvPr id="17" name="TextBox 16"/>
+          <p:cNvPr id="20" name="TextBox 19"/>
           <p:cNvSpPr txBox="1"/>
           <p:nvPr/>
         </p:nvSpPr>
         <p:spPr>
           <a:xfrm>
-            <a:off x="8705087" y="3401568"/>
-            <a:ext cx="768096" cy="274320"/>
+            <a:off x="10277855" y="3401568"/>
+            <a:ext cx="1115568" cy="274320"/>
           </a:xfrm>
           <a:prstGeom prst="rect">
             <a:avLst/>
@@ -25126,138 +25271,7 @@
                 </a:solidFill>
                 <a:latin typeface="Arial"/>
               </a:rPr>
-              <a:t>Unconfirmed</a:t>
-            </a:r>
-          </a:p>
-        </p:txBody>
-      </p:sp>
-      <p:sp>
-        <p:nvSpPr>
-          <p:cNvPr id="18" name="Rounded Rectangle 17"/>
-          <p:cNvSpPr/>
-          <p:nvPr/>
-        </p:nvSpPr>
-        <p:spPr>
-          <a:xfrm>
-            <a:off x="9564624" y="3401568"/>
-            <a:ext cx="1133856" cy="274320"/>
-          </a:xfrm>
-          <a:prstGeom prst="roundRect">
-            <a:avLst>
-              <a:gd name="adj" fmla="val 50000"/>
-            </a:avLst>
-          </a:prstGeom>
-          <a:solidFill>
-            <a:srgbClr val="E3F3EA"/>
-          </a:solidFill>
-          <a:ln w="12700">
-            <a:solidFill>
-              <a:srgbClr val="1C7340"/>
-            </a:solidFill>
-          </a:ln>
-          <a:effectLst/>
-        </p:spPr>
-        <p:style>
-          <a:lnRef idx="1">
-            <a:schemeClr val="accent1"/>
-          </a:lnRef>
-          <a:fillRef idx="3">
-            <a:schemeClr val="accent1"/>
-          </a:fillRef>
-          <a:effectRef idx="2">
-            <a:schemeClr val="accent1"/>
-          </a:effectRef>
-          <a:fontRef idx="minor">
-            <a:schemeClr val="lt1"/>
-          </a:fontRef>
-        </p:style>
-        <p:txBody>
-          <a:bodyPr rtlCol="0" anchor="ctr"/>
-          <a:lstStyle/>
-          <a:p>
-            <a:pPr algn="ctr"/>
-          </a:p>
-        </p:txBody>
-      </p:sp>
-      <p:sp>
-        <p:nvSpPr>
-          <p:cNvPr id="19" name="Oval 18"/>
-          <p:cNvSpPr/>
-          <p:nvPr/>
-        </p:nvSpPr>
-        <p:spPr>
-          <a:xfrm>
-            <a:off x="9710928" y="3483864"/>
-            <a:ext cx="109728" cy="109728"/>
-          </a:xfrm>
-          <a:prstGeom prst="ellipse">
-            <a:avLst/>
-          </a:prstGeom>
-          <a:solidFill>
-            <a:srgbClr val="1C7340"/>
-          </a:solidFill>
-          <a:ln>
-            <a:noFill/>
-          </a:ln>
-          <a:effectLst/>
-        </p:spPr>
-        <p:style>
-          <a:lnRef idx="1">
-            <a:schemeClr val="accent1"/>
-          </a:lnRef>
-          <a:fillRef idx="3">
-            <a:schemeClr val="accent1"/>
-          </a:fillRef>
-          <a:effectRef idx="2">
-            <a:schemeClr val="accent1"/>
-          </a:effectRef>
-          <a:fontRef idx="minor">
-            <a:schemeClr val="lt1"/>
-          </a:fontRef>
-        </p:style>
-        <p:txBody>
-          <a:bodyPr rtlCol="0" anchor="ctr"/>
-          <a:lstStyle/>
-          <a:p>
-            <a:pPr algn="ctr"/>
-          </a:p>
-        </p:txBody>
-      </p:sp>
-      <p:sp>
-        <p:nvSpPr>
-          <p:cNvPr id="20" name="TextBox 19"/>
-          <p:cNvSpPr txBox="1"/>
-          <p:nvPr/>
-        </p:nvSpPr>
-        <p:spPr>
-          <a:xfrm>
-            <a:off x="9893807" y="3401568"/>
-            <a:ext cx="768096" cy="274320"/>
-          </a:xfrm>
-          <a:prstGeom prst="rect">
-            <a:avLst/>
-          </a:prstGeom>
-          <a:noFill/>
-        </p:spPr>
-        <p:txBody>
-          <a:bodyPr wrap="square" lIns="0" rIns="0" tIns="0" bIns="0" anchor="ctr">
-            <a:spAutoFit/>
-          </a:bodyPr>
-          <a:lstStyle/>
-          <a:p>
-            <a:pPr algn="l">
-              <a:spcAft>
-                <a:spcPts val="0"/>
-              </a:spcAft>
-            </a:pPr>
-            <a:r>
-              <a:rPr sz="900" b="1">
-                <a:solidFill>
-                  <a:srgbClr val="1C7340"/>
-                </a:solidFill>
-                <a:latin typeface="Arial"/>
-              </a:rPr>
-              <a:t>Confirmed</a:t>
+              <a:t>Dotted = unconfirmed</a:t>
             </a:r>
           </a:p>
         </p:txBody>

</xml_diff>

<commit_message>
2. Credibility score; 1. Alerts for "My addresses" only within 50 m
</commit_message>
<xml_diff>
--- a/docs/WorkInProgress-Pitch.pptx
+++ b/docs/WorkInProgress-Pitch.pptx
@@ -1105,7 +1105,7 @@
           </a:p>
           <a:p>
             <a:r>
-              <a:t>"Two sources, one set of rules. Official data comes in automatically from four providers, every hour, placed on the real streets. A citizen report appears right away with a dotted outline, marked Unconfirmed, so neighbours can check it. Signed-in users who walk within 50 metres are asked: do you have this problem too? Anyone can also answer on the event page. Three 'yes' answers from people within 100 metres make it Confirmed. If at least three people answer 'no, mine works' and they outnumber the 'yes' answers, the report is Disputed and comes off the map. So false alarms and pranks correct themselves, without moderators. Old reports expire on their own."</a:t>
+              <a:t>"Two sources, one set of rules. Official data comes in automatically from four providers, every one to two hours, placed on the real streets. A citizen report appears right away with a dotted outline, marked Unconfirmed, so neighbours can check it. Signed-in users who walk within 50 metres are asked: do you have this problem too? Anyone can also answer on the event page. Three 'yes' answers from people within 100 metres make it Confirmed. If at least three people answer 'no, mine works' and they outnumber the 'yes' answers, the report is Disputed and comes off the map. So false alarms and pranks correct themselves, without moderators. Old reports expire on their own."</a:t>
             </a:r>
           </a:p>
           <a:p>
@@ -1185,7 +1185,7 @@
           </a:p>
           <a:p>
             <a:r>
-              <a:t>Status: working prototype, not yet deployed as a public bot.</a:t>
+              <a:t>Play the Telegram demo video on this slide (insert it into the frame on the right).</a:t>
             </a:r>
           </a:p>
         </p:txBody>
@@ -1345,7 +1345,7 @@
           </a:p>
           <a:p>
             <a:r>
-              <a:t>"We built one live map of every water, power and gas outage in Chișinău. Official announcements come in automatically from four providers, every hour. You see whether your saved addresses are affected and what's planned for the coming days. And neighbours confirm problems that nobody announced."</a:t>
+              <a:t>"We built one live map of every water, power and gas outage in Chișinău. Official announcements come in automatically from four providers, every one to two hours. You see whether your saved addresses are affected and what's planned for the coming days. And neighbours confirm problems that nobody announced."</a:t>
             </a:r>
           </a:p>
           <a:p>
@@ -1685,7 +1685,7 @@
           </a:p>
           <a:p>
             <a:r>
-              <a:t>"Four websites become one map. An announcement is on the map within an hour. And it covers all 720,000 people in Chișinău. 91% of the people we surveyed want this in one place, and 83% would use it. For the city, residents can prepare, and providers and City Hall get a live, verified picture of breakdowns."</a:t>
+              <a:t>"Four websites become one map. An announcement is on the map within two hours at most, within one for water and power. And it covers all 720,000 people in Chișinău. 91% of the people we surveyed want this in one place, and 83% would use it. For the city, residents can prepare, and providers and City Hall get a live, verified picture of breakdowns."</a:t>
             </a:r>
           </a:p>
         </p:txBody>
@@ -7337,7 +7337,7 @@
                 </a:solidFill>
                 <a:latin typeface="Arial"/>
               </a:rPr>
-              <a:t>Nothing is mocked: 4 live official feeds, real streets, real-time confirmations. Telegram reporting works as a prototype. Not built yet: alerts for saved addresses, the Telegram forecast, direct provider feeds.</a:t>
+              <a:t>Nothing is mocked: 4 live official feeds, real streets, real-time confirmations. Reporting from Telegram works. Not built yet: alerts for saved addresses, the Telegram forecast, direct provider feeds.</a:t>
             </a:r>
           </a:p>
         </p:txBody>
@@ -7765,7 +7765,7 @@
                 </a:solidFill>
                 <a:latin typeface="Arial"/>
               </a:rPr>
-              <a:t>A report needs an account, 3 "Me too" answers from people within 100 m, one answer per device, a Disputed status, and automatic expiry.</a:t>
+              <a:t>A report needs an account and 3 "Me too" answers from people within 100 m, one per device. Each author has a credibility score: +1 per "Me too", −0.5 per "Mine works"; below 40 they can't report for 7 days.</a:t>
             </a:r>
           </a:p>
         </p:txBody>
@@ -13381,25 +13381,28 @@
       </p:sp>
       <p:sp>
         <p:nvSpPr>
-          <p:cNvPr id="21" name="Rounded Rectangle 20"/>
+          <p:cNvPr id="21" name="Telegram video frame (replace with video)"/>
           <p:cNvSpPr/>
           <p:nvPr/>
         </p:nvSpPr>
         <p:spPr>
           <a:xfrm>
-            <a:off x="6949440" y="502920"/>
-            <a:ext cx="4690872" cy="5577840"/>
+            <a:off x="7726108" y="502920"/>
+            <a:ext cx="3137535" cy="5577840"/>
           </a:xfrm>
           <a:prstGeom prst="roundRect">
             <a:avLst>
-              <a:gd name="adj" fmla="val 5847"/>
+              <a:gd name="adj" fmla="val 8743"/>
             </a:avLst>
           </a:prstGeom>
           <a:solidFill>
             <a:srgbClr val="171B21"/>
           </a:solidFill>
-          <a:ln>
-            <a:noFill/>
+          <a:ln w="15875">
+            <a:solidFill>
+              <a:srgbClr val="3E4650"/>
+            </a:solidFill>
+            <a:prstDash val="dash"/>
           </a:ln>
           <a:effectLst/>
         </p:spPr>
@@ -13433,118 +13436,11 @@
         </p:nvSpPr>
         <p:spPr>
           <a:xfrm>
-            <a:off x="7223759" y="758952"/>
-            <a:ext cx="384048" cy="384048"/>
+            <a:off x="8883396" y="2606039"/>
+            <a:ext cx="822960" cy="822960"/>
           </a:xfrm>
           <a:prstGeom prst="ellipse">
             <a:avLst/>
-          </a:prstGeom>
-          <a:solidFill>
-            <a:srgbClr val="7AA7FF"/>
-          </a:solidFill>
-          <a:ln>
-            <a:noFill/>
-          </a:ln>
-          <a:effectLst/>
-        </p:spPr>
-        <p:style>
-          <a:lnRef idx="1">
-            <a:schemeClr val="accent1"/>
-          </a:lnRef>
-          <a:fillRef idx="3">
-            <a:schemeClr val="accent1"/>
-          </a:fillRef>
-          <a:effectRef idx="2">
-            <a:schemeClr val="accent1"/>
-          </a:effectRef>
-          <a:fontRef idx="minor">
-            <a:schemeClr val="lt1"/>
-          </a:fontRef>
-        </p:style>
-        <p:txBody>
-          <a:bodyPr rtlCol="0" anchor="ctr"/>
-          <a:lstStyle/>
-          <a:p>
-            <a:pPr algn="ctr"/>
-          </a:p>
-        </p:txBody>
-      </p:sp>
-      <p:sp>
-        <p:nvSpPr>
-          <p:cNvPr id="23" name="TextBox 22"/>
-          <p:cNvSpPr txBox="1"/>
-          <p:nvPr/>
-        </p:nvSpPr>
-        <p:spPr>
-          <a:xfrm>
-            <a:off x="7726679" y="731520"/>
-            <a:ext cx="3200400" cy="457200"/>
-          </a:xfrm>
-          <a:prstGeom prst="rect">
-            <a:avLst/>
-          </a:prstGeom>
-          <a:noFill/>
-        </p:spPr>
-        <p:txBody>
-          <a:bodyPr wrap="square" lIns="0" rIns="0" tIns="0" bIns="0" anchor="t">
-            <a:spAutoFit/>
-          </a:bodyPr>
-          <a:lstStyle/>
-          <a:p>
-            <a:pPr algn="l">
-              <a:lnSpc>
-                <a:spcPct val="100000"/>
-              </a:lnSpc>
-              <a:spcAft>
-                <a:spcPts val="0"/>
-              </a:spcAft>
-            </a:pPr>
-            <a:r>
-              <a:rPr sz="1200" b="1">
-                <a:solidFill>
-                  <a:srgbClr val="ECEEF1"/>
-                </a:solidFill>
-                <a:latin typeface="Arial"/>
-              </a:rPr>
-              <a:t>Work In Progress bot</a:t>
-            </a:r>
-          </a:p>
-          <a:p>
-            <a:pPr algn="l">
-              <a:lnSpc>
-                <a:spcPct val="100000"/>
-              </a:lnSpc>
-              <a:spcAft>
-                <a:spcPts val="0"/>
-              </a:spcAft>
-            </a:pPr>
-            <a:r>
-              <a:rPr sz="950" b="0">
-                <a:solidFill>
-                  <a:srgbClr val="A9B0B9"/>
-                </a:solidFill>
-                <a:latin typeface="Arial"/>
-              </a:rPr>
-              <a:t>bot · replies in Romanian</a:t>
-            </a:r>
-          </a:p>
-        </p:txBody>
-      </p:sp>
-      <p:sp>
-        <p:nvSpPr>
-          <p:cNvPr id="24" name="Rounded Rectangle 23"/>
-          <p:cNvSpPr/>
-          <p:nvPr/>
-        </p:nvSpPr>
-        <p:spPr>
-          <a:xfrm>
-            <a:off x="9948672" y="1417320"/>
-            <a:ext cx="1463040" cy="384048"/>
-          </a:xfrm>
-          <a:prstGeom prst="roundRect">
-            <a:avLst>
-              <a:gd name="adj" fmla="val 33333"/>
-            </a:avLst>
           </a:prstGeom>
           <a:solidFill>
             <a:srgbClr val="ECEEF1"/>
@@ -13578,69 +13474,24 @@
       </p:sp>
       <p:sp>
         <p:nvSpPr>
-          <p:cNvPr id="25" name="TextBox 24"/>
-          <p:cNvSpPr txBox="1"/>
-          <p:nvPr/>
-        </p:nvSpPr>
-        <p:spPr>
-          <a:xfrm>
-            <a:off x="10113264" y="1417320"/>
-            <a:ext cx="1133856" cy="384048"/>
-          </a:xfrm>
-          <a:prstGeom prst="rect">
-            <a:avLst/>
-          </a:prstGeom>
-          <a:noFill/>
-        </p:spPr>
-        <p:txBody>
-          <a:bodyPr wrap="square" lIns="0" rIns="0" tIns="0" bIns="0" anchor="ctr">
-            <a:spAutoFit/>
-          </a:bodyPr>
-          <a:lstStyle/>
-          <a:p>
-            <a:pPr algn="l">
-              <a:lnSpc>
-                <a:spcPct val="105000"/>
-              </a:lnSpc>
-              <a:spcAft>
-                <a:spcPts val="0"/>
-              </a:spcAft>
-            </a:pPr>
-            <a:r>
-              <a:rPr sz="1100" b="1">
-                <a:solidFill>
-                  <a:srgbClr val="0F1216"/>
-                </a:solidFill>
-                <a:latin typeface="Arial"/>
-              </a:rPr>
-              <a:t>/raporteaza</a:t>
-            </a:r>
-          </a:p>
-        </p:txBody>
-      </p:sp>
-      <p:sp>
-        <p:nvSpPr>
-          <p:cNvPr id="26" name="Rounded Rectangle 25"/>
+          <p:cNvPr id="23" name="Isosceles Triangle 22"/>
           <p:cNvSpPr/>
           <p:nvPr/>
         </p:nvSpPr>
         <p:spPr>
-          <a:xfrm>
-            <a:off x="7178040" y="1920240"/>
-            <a:ext cx="3291840" cy="384048"/>
-          </a:xfrm>
-          <a:prstGeom prst="roundRect">
-            <a:avLst>
-              <a:gd name="adj" fmla="val 33333"/>
-            </a:avLst>
+          <a:xfrm rot="5400000">
+            <a:off x="9203436" y="2834639"/>
+            <a:ext cx="365760" cy="338328"/>
+          </a:xfrm>
+          <a:prstGeom prst="triangle">
+            <a:avLst/>
           </a:prstGeom>
           <a:solidFill>
-            <a:srgbClr val="1F242B"/>
+            <a:srgbClr val="0F1216"/>
           </a:solidFill>
           <a:ln>
             <a:noFill/>
           </a:ln>
-          <a:effectLst/>
         </p:spPr>
         <p:style>
           <a:lnRef idx="1">
@@ -13666,971 +13517,14 @@
       </p:sp>
       <p:sp>
         <p:nvSpPr>
-          <p:cNvPr id="27" name="TextBox 26"/>
+          <p:cNvPr id="24" name="TextBox 23"/>
           <p:cNvSpPr txBox="1"/>
           <p:nvPr/>
         </p:nvSpPr>
         <p:spPr>
           <a:xfrm>
-            <a:off x="7342631" y="1920240"/>
-            <a:ext cx="2962656" cy="384048"/>
-          </a:xfrm>
-          <a:prstGeom prst="rect">
-            <a:avLst/>
-          </a:prstGeom>
-          <a:noFill/>
-        </p:spPr>
-        <p:txBody>
-          <a:bodyPr wrap="square" lIns="0" rIns="0" tIns="0" bIns="0" anchor="ctr">
-            <a:spAutoFit/>
-          </a:bodyPr>
-          <a:lstStyle/>
-          <a:p>
-            <a:pPr algn="l">
-              <a:lnSpc>
-                <a:spcPct val="105000"/>
-              </a:lnSpc>
-              <a:spcAft>
-                <a:spcPts val="0"/>
-              </a:spcAft>
-            </a:pPr>
-            <a:r>
-              <a:rPr sz="1100" b="0">
-                <a:solidFill>
-                  <a:srgbClr val="ECEEF1"/>
-                </a:solidFill>
-                <a:latin typeface="Arial"/>
-              </a:rPr>
-              <a:t>What problem do you want to report?</a:t>
-            </a:r>
-          </a:p>
-        </p:txBody>
-      </p:sp>
-      <p:sp>
-        <p:nvSpPr>
-          <p:cNvPr id="28" name="Rounded Rectangle 27"/>
-          <p:cNvSpPr/>
-          <p:nvPr/>
-        </p:nvSpPr>
-        <p:spPr>
-          <a:xfrm>
-            <a:off x="7178040" y="2350008"/>
-            <a:ext cx="1048512" cy="329184"/>
-          </a:xfrm>
-          <a:prstGeom prst="roundRect">
-            <a:avLst>
-              <a:gd name="adj" fmla="val 27777"/>
-            </a:avLst>
-          </a:prstGeom>
-          <a:solidFill>
-            <a:srgbClr val="2A3038"/>
-          </a:solidFill>
-          <a:ln>
-            <a:noFill/>
-          </a:ln>
-          <a:effectLst/>
-        </p:spPr>
-        <p:style>
-          <a:lnRef idx="1">
-            <a:schemeClr val="accent1"/>
-          </a:lnRef>
-          <a:fillRef idx="3">
-            <a:schemeClr val="accent1"/>
-          </a:fillRef>
-          <a:effectRef idx="2">
-            <a:schemeClr val="accent1"/>
-          </a:effectRef>
-          <a:fontRef idx="minor">
-            <a:schemeClr val="lt1"/>
-          </a:fontRef>
-        </p:style>
-        <p:txBody>
-          <a:bodyPr rtlCol="0" anchor="ctr"/>
-          <a:lstStyle/>
-          <a:p>
-            <a:pPr algn="ctr"/>
-          </a:p>
-        </p:txBody>
-      </p:sp>
-      <p:sp>
-        <p:nvSpPr>
-          <p:cNvPr id="29" name="TextBox 28"/>
-          <p:cNvSpPr txBox="1"/>
-          <p:nvPr/>
-        </p:nvSpPr>
-        <p:spPr>
-          <a:xfrm>
-            <a:off x="7223759" y="2350008"/>
-            <a:ext cx="957072" cy="329184"/>
-          </a:xfrm>
-          <a:prstGeom prst="rect">
-            <a:avLst/>
-          </a:prstGeom>
-          <a:noFill/>
-        </p:spPr>
-        <p:txBody>
-          <a:bodyPr wrap="square" lIns="0" rIns="0" tIns="0" bIns="0" anchor="ctr">
-            <a:spAutoFit/>
-          </a:bodyPr>
-          <a:lstStyle/>
-          <a:p>
-            <a:pPr algn="ctr">
-              <a:spcAft>
-                <a:spcPts val="0"/>
-              </a:spcAft>
-            </a:pPr>
-            <a:r>
-              <a:rPr sz="950" b="1">
-                <a:solidFill>
-                  <a:srgbClr val="ECEEF1"/>
-                </a:solidFill>
-                <a:latin typeface="Arial"/>
-              </a:rPr>
-              <a:t>Water</a:t>
-            </a:r>
-          </a:p>
-        </p:txBody>
-      </p:sp>
-      <p:sp>
-        <p:nvSpPr>
-          <p:cNvPr id="30" name="Rounded Rectangle 29"/>
-          <p:cNvSpPr/>
-          <p:nvPr/>
-        </p:nvSpPr>
-        <p:spPr>
-          <a:xfrm>
-            <a:off x="8299704" y="2350008"/>
-            <a:ext cx="1048512" cy="329184"/>
-          </a:xfrm>
-          <a:prstGeom prst="roundRect">
-            <a:avLst>
-              <a:gd name="adj" fmla="val 27777"/>
-            </a:avLst>
-          </a:prstGeom>
-          <a:solidFill>
-            <a:srgbClr val="2A3038"/>
-          </a:solidFill>
-          <a:ln>
-            <a:noFill/>
-          </a:ln>
-          <a:effectLst/>
-        </p:spPr>
-        <p:style>
-          <a:lnRef idx="1">
-            <a:schemeClr val="accent1"/>
-          </a:lnRef>
-          <a:fillRef idx="3">
-            <a:schemeClr val="accent1"/>
-          </a:fillRef>
-          <a:effectRef idx="2">
-            <a:schemeClr val="accent1"/>
-          </a:effectRef>
-          <a:fontRef idx="minor">
-            <a:schemeClr val="lt1"/>
-          </a:fontRef>
-        </p:style>
-        <p:txBody>
-          <a:bodyPr rtlCol="0" anchor="ctr"/>
-          <a:lstStyle/>
-          <a:p>
-            <a:pPr algn="ctr"/>
-          </a:p>
-        </p:txBody>
-      </p:sp>
-      <p:sp>
-        <p:nvSpPr>
-          <p:cNvPr id="31" name="TextBox 30"/>
-          <p:cNvSpPr txBox="1"/>
-          <p:nvPr/>
-        </p:nvSpPr>
-        <p:spPr>
-          <a:xfrm>
-            <a:off x="8345424" y="2350008"/>
-            <a:ext cx="957072" cy="329184"/>
-          </a:xfrm>
-          <a:prstGeom prst="rect">
-            <a:avLst/>
-          </a:prstGeom>
-          <a:noFill/>
-        </p:spPr>
-        <p:txBody>
-          <a:bodyPr wrap="square" lIns="0" rIns="0" tIns="0" bIns="0" anchor="ctr">
-            <a:spAutoFit/>
-          </a:bodyPr>
-          <a:lstStyle/>
-          <a:p>
-            <a:pPr algn="ctr">
-              <a:spcAft>
-                <a:spcPts val="0"/>
-              </a:spcAft>
-            </a:pPr>
-            <a:r>
-              <a:rPr sz="950" b="1">
-                <a:solidFill>
-                  <a:srgbClr val="ECEEF1"/>
-                </a:solidFill>
-                <a:latin typeface="Arial"/>
-              </a:rPr>
-              <a:t>Gas</a:t>
-            </a:r>
-          </a:p>
-        </p:txBody>
-      </p:sp>
-      <p:sp>
-        <p:nvSpPr>
-          <p:cNvPr id="32" name="Rounded Rectangle 31"/>
-          <p:cNvSpPr/>
-          <p:nvPr/>
-        </p:nvSpPr>
-        <p:spPr>
-          <a:xfrm>
-            <a:off x="9421368" y="2350008"/>
-            <a:ext cx="1048512" cy="329184"/>
-          </a:xfrm>
-          <a:prstGeom prst="roundRect">
-            <a:avLst>
-              <a:gd name="adj" fmla="val 27777"/>
-            </a:avLst>
-          </a:prstGeom>
-          <a:solidFill>
-            <a:srgbClr val="2A3038"/>
-          </a:solidFill>
-          <a:ln>
-            <a:noFill/>
-          </a:ln>
-          <a:effectLst/>
-        </p:spPr>
-        <p:style>
-          <a:lnRef idx="1">
-            <a:schemeClr val="accent1"/>
-          </a:lnRef>
-          <a:fillRef idx="3">
-            <a:schemeClr val="accent1"/>
-          </a:fillRef>
-          <a:effectRef idx="2">
-            <a:schemeClr val="accent1"/>
-          </a:effectRef>
-          <a:fontRef idx="minor">
-            <a:schemeClr val="lt1"/>
-          </a:fontRef>
-        </p:style>
-        <p:txBody>
-          <a:bodyPr rtlCol="0" anchor="ctr"/>
-          <a:lstStyle/>
-          <a:p>
-            <a:pPr algn="ctr"/>
-          </a:p>
-        </p:txBody>
-      </p:sp>
-      <p:sp>
-        <p:nvSpPr>
-          <p:cNvPr id="33" name="TextBox 32"/>
-          <p:cNvSpPr txBox="1"/>
-          <p:nvPr/>
-        </p:nvSpPr>
-        <p:spPr>
-          <a:xfrm>
-            <a:off x="9467088" y="2350008"/>
-            <a:ext cx="957072" cy="329184"/>
-          </a:xfrm>
-          <a:prstGeom prst="rect">
-            <a:avLst/>
-          </a:prstGeom>
-          <a:noFill/>
-        </p:spPr>
-        <p:txBody>
-          <a:bodyPr wrap="square" lIns="0" rIns="0" tIns="0" bIns="0" anchor="ctr">
-            <a:spAutoFit/>
-          </a:bodyPr>
-          <a:lstStyle/>
-          <a:p>
-            <a:pPr algn="ctr">
-              <a:spcAft>
-                <a:spcPts val="0"/>
-              </a:spcAft>
-            </a:pPr>
-            <a:r>
-              <a:rPr sz="950" b="1">
-                <a:solidFill>
-                  <a:srgbClr val="ECEEF1"/>
-                </a:solidFill>
-                <a:latin typeface="Arial"/>
-              </a:rPr>
-              <a:t>Electricity</a:t>
-            </a:r>
-          </a:p>
-        </p:txBody>
-      </p:sp>
-      <p:sp>
-        <p:nvSpPr>
-          <p:cNvPr id="34" name="Rounded Rectangle 33"/>
-          <p:cNvSpPr/>
-          <p:nvPr/>
-        </p:nvSpPr>
-        <p:spPr>
-          <a:xfrm>
-            <a:off x="10405872" y="2834639"/>
-            <a:ext cx="1005840" cy="384048"/>
-          </a:xfrm>
-          <a:prstGeom prst="roundRect">
-            <a:avLst>
-              <a:gd name="adj" fmla="val 33333"/>
-            </a:avLst>
-          </a:prstGeom>
-          <a:solidFill>
-            <a:srgbClr val="ECEEF1"/>
-          </a:solidFill>
-          <a:ln>
-            <a:noFill/>
-          </a:ln>
-          <a:effectLst/>
-        </p:spPr>
-        <p:style>
-          <a:lnRef idx="1">
-            <a:schemeClr val="accent1"/>
-          </a:lnRef>
-          <a:fillRef idx="3">
-            <a:schemeClr val="accent1"/>
-          </a:fillRef>
-          <a:effectRef idx="2">
-            <a:schemeClr val="accent1"/>
-          </a:effectRef>
-          <a:fontRef idx="minor">
-            <a:schemeClr val="lt1"/>
-          </a:fontRef>
-        </p:style>
-        <p:txBody>
-          <a:bodyPr rtlCol="0" anchor="ctr"/>
-          <a:lstStyle/>
-          <a:p>
-            <a:pPr algn="ctr"/>
-          </a:p>
-        </p:txBody>
-      </p:sp>
-      <p:sp>
-        <p:nvSpPr>
-          <p:cNvPr id="35" name="TextBox 34"/>
-          <p:cNvSpPr txBox="1"/>
-          <p:nvPr/>
-        </p:nvSpPr>
-        <p:spPr>
-          <a:xfrm>
-            <a:off x="10570464" y="2834639"/>
-            <a:ext cx="676656" cy="384048"/>
-          </a:xfrm>
-          <a:prstGeom prst="rect">
-            <a:avLst/>
-          </a:prstGeom>
-          <a:noFill/>
-        </p:spPr>
-        <p:txBody>
-          <a:bodyPr wrap="square" lIns="0" rIns="0" tIns="0" bIns="0" anchor="ctr">
-            <a:spAutoFit/>
-          </a:bodyPr>
-          <a:lstStyle/>
-          <a:p>
-            <a:pPr algn="l">
-              <a:lnSpc>
-                <a:spcPct val="105000"/>
-              </a:lnSpc>
-              <a:spcAft>
-                <a:spcPts val="0"/>
-              </a:spcAft>
-            </a:pPr>
-            <a:r>
-              <a:rPr sz="1100" b="1">
-                <a:solidFill>
-                  <a:srgbClr val="0F1216"/>
-                </a:solidFill>
-                <a:latin typeface="Arial"/>
-              </a:rPr>
-              <a:t>Water</a:t>
-            </a:r>
-          </a:p>
-        </p:txBody>
-      </p:sp>
-      <p:sp>
-        <p:nvSpPr>
-          <p:cNvPr id="36" name="Rounded Rectangle 35"/>
-          <p:cNvSpPr/>
-          <p:nvPr/>
-        </p:nvSpPr>
-        <p:spPr>
-          <a:xfrm>
-            <a:off x="7178040" y="3337560"/>
-            <a:ext cx="3291840" cy="566928"/>
-          </a:xfrm>
-          <a:prstGeom prst="roundRect">
-            <a:avLst>
-              <a:gd name="adj" fmla="val 22580"/>
-            </a:avLst>
-          </a:prstGeom>
-          <a:solidFill>
-            <a:srgbClr val="1F242B"/>
-          </a:solidFill>
-          <a:ln>
-            <a:noFill/>
-          </a:ln>
-          <a:effectLst/>
-        </p:spPr>
-        <p:style>
-          <a:lnRef idx="1">
-            <a:schemeClr val="accent1"/>
-          </a:lnRef>
-          <a:fillRef idx="3">
-            <a:schemeClr val="accent1"/>
-          </a:fillRef>
-          <a:effectRef idx="2">
-            <a:schemeClr val="accent1"/>
-          </a:effectRef>
-          <a:fontRef idx="minor">
-            <a:schemeClr val="lt1"/>
-          </a:fontRef>
-        </p:style>
-        <p:txBody>
-          <a:bodyPr rtlCol="0" anchor="ctr"/>
-          <a:lstStyle/>
-          <a:p>
-            <a:pPr algn="ctr"/>
-          </a:p>
-        </p:txBody>
-      </p:sp>
-      <p:sp>
-        <p:nvSpPr>
-          <p:cNvPr id="37" name="TextBox 36"/>
-          <p:cNvSpPr txBox="1"/>
-          <p:nvPr/>
-        </p:nvSpPr>
-        <p:spPr>
-          <a:xfrm>
-            <a:off x="7342631" y="3337560"/>
-            <a:ext cx="2962656" cy="566928"/>
-          </a:xfrm>
-          <a:prstGeom prst="rect">
-            <a:avLst/>
-          </a:prstGeom>
-          <a:noFill/>
-        </p:spPr>
-        <p:txBody>
-          <a:bodyPr wrap="square" lIns="0" rIns="0" tIns="0" bIns="0" anchor="ctr">
-            <a:spAutoFit/>
-          </a:bodyPr>
-          <a:lstStyle/>
-          <a:p>
-            <a:pPr algn="l">
-              <a:lnSpc>
-                <a:spcPct val="105000"/>
-              </a:lnSpc>
-              <a:spcAft>
-                <a:spcPts val="0"/>
-              </a:spcAft>
-            </a:pPr>
-            <a:r>
-              <a:rPr sz="1100" b="0">
-                <a:solidFill>
-                  <a:srgbClr val="ECEEF1"/>
-                </a:solidFill>
-                <a:latin typeface="Arial"/>
-              </a:rPr>
-              <a:t>Is it happening now, or starting later?</a:t>
-            </a:r>
-          </a:p>
-        </p:txBody>
-      </p:sp>
-      <p:sp>
-        <p:nvSpPr>
-          <p:cNvPr id="38" name="Rounded Rectangle 37"/>
-          <p:cNvSpPr/>
-          <p:nvPr/>
-        </p:nvSpPr>
-        <p:spPr>
-          <a:xfrm>
-            <a:off x="7178040" y="3950208"/>
-            <a:ext cx="1609344" cy="329184"/>
-          </a:xfrm>
-          <a:prstGeom prst="roundRect">
-            <a:avLst>
-              <a:gd name="adj" fmla="val 27777"/>
-            </a:avLst>
-          </a:prstGeom>
-          <a:solidFill>
-            <a:srgbClr val="2A3038"/>
-          </a:solidFill>
-          <a:ln>
-            <a:noFill/>
-          </a:ln>
-          <a:effectLst/>
-        </p:spPr>
-        <p:style>
-          <a:lnRef idx="1">
-            <a:schemeClr val="accent1"/>
-          </a:lnRef>
-          <a:fillRef idx="3">
-            <a:schemeClr val="accent1"/>
-          </a:fillRef>
-          <a:effectRef idx="2">
-            <a:schemeClr val="accent1"/>
-          </a:effectRef>
-          <a:fontRef idx="minor">
-            <a:schemeClr val="lt1"/>
-          </a:fontRef>
-        </p:style>
-        <p:txBody>
-          <a:bodyPr rtlCol="0" anchor="ctr"/>
-          <a:lstStyle/>
-          <a:p>
-            <a:pPr algn="ctr"/>
-          </a:p>
-        </p:txBody>
-      </p:sp>
-      <p:sp>
-        <p:nvSpPr>
-          <p:cNvPr id="39" name="TextBox 38"/>
-          <p:cNvSpPr txBox="1"/>
-          <p:nvPr/>
-        </p:nvSpPr>
-        <p:spPr>
-          <a:xfrm>
-            <a:off x="7223759" y="3950208"/>
-            <a:ext cx="1517904" cy="329184"/>
-          </a:xfrm>
-          <a:prstGeom prst="rect">
-            <a:avLst/>
-          </a:prstGeom>
-          <a:noFill/>
-        </p:spPr>
-        <p:txBody>
-          <a:bodyPr wrap="square" lIns="0" rIns="0" tIns="0" bIns="0" anchor="ctr">
-            <a:spAutoFit/>
-          </a:bodyPr>
-          <a:lstStyle/>
-          <a:p>
-            <a:pPr algn="ctr">
-              <a:spcAft>
-                <a:spcPts val="0"/>
-              </a:spcAft>
-            </a:pPr>
-            <a:r>
-              <a:rPr sz="950" b="1">
-                <a:solidFill>
-                  <a:srgbClr val="ECEEF1"/>
-                </a:solidFill>
-                <a:latin typeface="Arial"/>
-              </a:rPr>
-              <a:t>Happening now</a:t>
-            </a:r>
-          </a:p>
-        </p:txBody>
-      </p:sp>
-      <p:sp>
-        <p:nvSpPr>
-          <p:cNvPr id="40" name="Rounded Rectangle 39"/>
-          <p:cNvSpPr/>
-          <p:nvPr/>
-        </p:nvSpPr>
-        <p:spPr>
-          <a:xfrm>
-            <a:off x="8860536" y="3950208"/>
-            <a:ext cx="1609344" cy="329184"/>
-          </a:xfrm>
-          <a:prstGeom prst="roundRect">
-            <a:avLst>
-              <a:gd name="adj" fmla="val 27777"/>
-            </a:avLst>
-          </a:prstGeom>
-          <a:solidFill>
-            <a:srgbClr val="2A3038"/>
-          </a:solidFill>
-          <a:ln>
-            <a:noFill/>
-          </a:ln>
-          <a:effectLst/>
-        </p:spPr>
-        <p:style>
-          <a:lnRef idx="1">
-            <a:schemeClr val="accent1"/>
-          </a:lnRef>
-          <a:fillRef idx="3">
-            <a:schemeClr val="accent1"/>
-          </a:fillRef>
-          <a:effectRef idx="2">
-            <a:schemeClr val="accent1"/>
-          </a:effectRef>
-          <a:fontRef idx="minor">
-            <a:schemeClr val="lt1"/>
-          </a:fontRef>
-        </p:style>
-        <p:txBody>
-          <a:bodyPr rtlCol="0" anchor="ctr"/>
-          <a:lstStyle/>
-          <a:p>
-            <a:pPr algn="ctr"/>
-          </a:p>
-        </p:txBody>
-      </p:sp>
-      <p:sp>
-        <p:nvSpPr>
-          <p:cNvPr id="41" name="TextBox 40"/>
-          <p:cNvSpPr txBox="1"/>
-          <p:nvPr/>
-        </p:nvSpPr>
-        <p:spPr>
-          <a:xfrm>
-            <a:off x="8906256" y="3950208"/>
-            <a:ext cx="1517904" cy="329184"/>
-          </a:xfrm>
-          <a:prstGeom prst="rect">
-            <a:avLst/>
-          </a:prstGeom>
-          <a:noFill/>
-        </p:spPr>
-        <p:txBody>
-          <a:bodyPr wrap="square" lIns="0" rIns="0" tIns="0" bIns="0" anchor="ctr">
-            <a:spAutoFit/>
-          </a:bodyPr>
-          <a:lstStyle/>
-          <a:p>
-            <a:pPr algn="ctr">
-              <a:spcAft>
-                <a:spcPts val="0"/>
-              </a:spcAft>
-            </a:pPr>
-            <a:r>
-              <a:rPr sz="950" b="1">
-                <a:solidFill>
-                  <a:srgbClr val="ECEEF1"/>
-                </a:solidFill>
-                <a:latin typeface="Arial"/>
-              </a:rPr>
-              <a:t>Upcoming</a:t>
-            </a:r>
-          </a:p>
-        </p:txBody>
-      </p:sp>
-      <p:sp>
-        <p:nvSpPr>
-          <p:cNvPr id="42" name="Rounded Rectangle 41"/>
-          <p:cNvSpPr/>
-          <p:nvPr/>
-        </p:nvSpPr>
-        <p:spPr>
-          <a:xfrm>
-            <a:off x="7178040" y="4434840"/>
-            <a:ext cx="3291840" cy="384048"/>
-          </a:xfrm>
-          <a:prstGeom prst="roundRect">
-            <a:avLst>
-              <a:gd name="adj" fmla="val 33333"/>
-            </a:avLst>
-          </a:prstGeom>
-          <a:solidFill>
-            <a:srgbClr val="1F242B"/>
-          </a:solidFill>
-          <a:ln>
-            <a:noFill/>
-          </a:ln>
-          <a:effectLst/>
-        </p:spPr>
-        <p:style>
-          <a:lnRef idx="1">
-            <a:schemeClr val="accent1"/>
-          </a:lnRef>
-          <a:fillRef idx="3">
-            <a:schemeClr val="accent1"/>
-          </a:fillRef>
-          <a:effectRef idx="2">
-            <a:schemeClr val="accent1"/>
-          </a:effectRef>
-          <a:fontRef idx="minor">
-            <a:schemeClr val="lt1"/>
-          </a:fontRef>
-        </p:style>
-        <p:txBody>
-          <a:bodyPr rtlCol="0" anchor="ctr"/>
-          <a:lstStyle/>
-          <a:p>
-            <a:pPr algn="ctr"/>
-          </a:p>
-        </p:txBody>
-      </p:sp>
-      <p:sp>
-        <p:nvSpPr>
-          <p:cNvPr id="43" name="TextBox 42"/>
-          <p:cNvSpPr txBox="1"/>
-          <p:nvPr/>
-        </p:nvSpPr>
-        <p:spPr>
-          <a:xfrm>
-            <a:off x="7342631" y="4434840"/>
-            <a:ext cx="2962656" cy="384048"/>
-          </a:xfrm>
-          <a:prstGeom prst="rect">
-            <a:avLst/>
-          </a:prstGeom>
-          <a:noFill/>
-        </p:spPr>
-        <p:txBody>
-          <a:bodyPr wrap="square" lIns="0" rIns="0" tIns="0" bIns="0" anchor="ctr">
-            <a:spAutoFit/>
-          </a:bodyPr>
-          <a:lstStyle/>
-          <a:p>
-            <a:pPr algn="l">
-              <a:lnSpc>
-                <a:spcPct val="105000"/>
-              </a:lnSpc>
-              <a:spcAft>
-                <a:spcPts val="0"/>
-              </a:spcAft>
-            </a:pPr>
-            <a:r>
-              <a:rPr sz="1100" b="0">
-                <a:solidFill>
-                  <a:srgbClr val="ECEEF1"/>
-                </a:solidFill>
-                <a:latin typeface="Arial"/>
-              </a:rPr>
-              <a:t>Send the location of the problem.</a:t>
-            </a:r>
-          </a:p>
-        </p:txBody>
-      </p:sp>
-      <p:sp>
-        <p:nvSpPr>
-          <p:cNvPr id="44" name="Rounded Rectangle 43"/>
-          <p:cNvSpPr/>
-          <p:nvPr/>
-        </p:nvSpPr>
-        <p:spPr>
-          <a:xfrm>
-            <a:off x="7178040" y="4864607"/>
-            <a:ext cx="1828800" cy="329184"/>
-          </a:xfrm>
-          <a:prstGeom prst="roundRect">
-            <a:avLst>
-              <a:gd name="adj" fmla="val 27777"/>
-            </a:avLst>
-          </a:prstGeom>
-          <a:solidFill>
-            <a:srgbClr val="2A3038"/>
-          </a:solidFill>
-          <a:ln>
-            <a:noFill/>
-          </a:ln>
-          <a:effectLst/>
-        </p:spPr>
-        <p:style>
-          <a:lnRef idx="1">
-            <a:schemeClr val="accent1"/>
-          </a:lnRef>
-          <a:fillRef idx="3">
-            <a:schemeClr val="accent1"/>
-          </a:fillRef>
-          <a:effectRef idx="2">
-            <a:schemeClr val="accent1"/>
-          </a:effectRef>
-          <a:fontRef idx="minor">
-            <a:schemeClr val="lt1"/>
-          </a:fontRef>
-        </p:style>
-        <p:txBody>
-          <a:bodyPr rtlCol="0" anchor="ctr"/>
-          <a:lstStyle/>
-          <a:p>
-            <a:pPr algn="ctr"/>
-          </a:p>
-        </p:txBody>
-      </p:sp>
-      <p:sp>
-        <p:nvSpPr>
-          <p:cNvPr id="45" name="TextBox 44"/>
-          <p:cNvSpPr txBox="1"/>
-          <p:nvPr/>
-        </p:nvSpPr>
-        <p:spPr>
-          <a:xfrm>
-            <a:off x="7223759" y="4864607"/>
-            <a:ext cx="1737360" cy="329184"/>
-          </a:xfrm>
-          <a:prstGeom prst="rect">
-            <a:avLst/>
-          </a:prstGeom>
-          <a:noFill/>
-        </p:spPr>
-        <p:txBody>
-          <a:bodyPr wrap="square" lIns="0" rIns="0" tIns="0" bIns="0" anchor="ctr">
-            <a:spAutoFit/>
-          </a:bodyPr>
-          <a:lstStyle/>
-          <a:p>
-            <a:pPr algn="ctr">
-              <a:spcAft>
-                <a:spcPts val="0"/>
-              </a:spcAft>
-            </a:pPr>
-            <a:r>
-              <a:rPr sz="950" b="1">
-                <a:solidFill>
-                  <a:srgbClr val="ECEEF1"/>
-                </a:solidFill>
-                <a:latin typeface="Arial"/>
-              </a:rPr>
-              <a:t>Send location</a:t>
-            </a:r>
-          </a:p>
-        </p:txBody>
-      </p:sp>
-      <p:sp>
-        <p:nvSpPr>
-          <p:cNvPr id="46" name="Rounded Rectangle 45"/>
-          <p:cNvSpPr/>
-          <p:nvPr/>
-        </p:nvSpPr>
-        <p:spPr>
-          <a:xfrm>
-            <a:off x="7178040" y="5349240"/>
-            <a:ext cx="3291840" cy="475488"/>
-          </a:xfrm>
-          <a:prstGeom prst="roundRect">
-            <a:avLst>
-              <a:gd name="adj" fmla="val 26923"/>
-            </a:avLst>
-          </a:prstGeom>
-          <a:solidFill>
-            <a:srgbClr val="1F242B"/>
-          </a:solidFill>
-          <a:ln>
-            <a:noFill/>
-          </a:ln>
-          <a:effectLst/>
-        </p:spPr>
-        <p:style>
-          <a:lnRef idx="1">
-            <a:schemeClr val="accent1"/>
-          </a:lnRef>
-          <a:fillRef idx="3">
-            <a:schemeClr val="accent1"/>
-          </a:fillRef>
-          <a:effectRef idx="2">
-            <a:schemeClr val="accent1"/>
-          </a:effectRef>
-          <a:fontRef idx="minor">
-            <a:schemeClr val="lt1"/>
-          </a:fontRef>
-        </p:style>
-        <p:txBody>
-          <a:bodyPr rtlCol="0" anchor="ctr"/>
-          <a:lstStyle/>
-          <a:p>
-            <a:pPr algn="ctr"/>
-          </a:p>
-        </p:txBody>
-      </p:sp>
-      <p:sp>
-        <p:nvSpPr>
-          <p:cNvPr id="47" name="TextBox 46"/>
-          <p:cNvSpPr txBox="1"/>
-          <p:nvPr/>
-        </p:nvSpPr>
-        <p:spPr>
-          <a:xfrm>
-            <a:off x="7342631" y="5349240"/>
-            <a:ext cx="2962656" cy="475488"/>
-          </a:xfrm>
-          <a:prstGeom prst="rect">
-            <a:avLst/>
-          </a:prstGeom>
-          <a:noFill/>
-        </p:spPr>
-        <p:txBody>
-          <a:bodyPr wrap="square" lIns="0" rIns="0" tIns="0" bIns="0" anchor="ctr">
-            <a:spAutoFit/>
-          </a:bodyPr>
-          <a:lstStyle/>
-          <a:p>
-            <a:pPr algn="l">
-              <a:lnSpc>
-                <a:spcPct val="105000"/>
-              </a:lnSpc>
-              <a:spcAft>
-                <a:spcPts val="0"/>
-              </a:spcAft>
-            </a:pPr>
-            <a:r>
-              <a:rPr sz="1100" b="1">
-                <a:solidFill>
-                  <a:srgbClr val="ECEEF1"/>
-                </a:solidFill>
-                <a:latin typeface="Arial"/>
-              </a:rPr>
-              <a:t>Report sent. </a:t>
-            </a:r>
-            <a:r>
-              <a:rPr sz="1100" b="0">
-                <a:solidFill>
-                  <a:srgbClr val="ECEEF1"/>
-                </a:solidFill>
-                <a:latin typeface="Arial"/>
-              </a:rPr>
-              <a:t>Neighbours nearby confirm it.</a:t>
-            </a:r>
-          </a:p>
-        </p:txBody>
-      </p:sp>
-      <p:sp>
-        <p:nvSpPr>
-          <p:cNvPr id="48" name="Oval 47"/>
-          <p:cNvSpPr/>
-          <p:nvPr/>
-        </p:nvSpPr>
-        <p:spPr>
-          <a:xfrm>
-            <a:off x="7315200" y="5522976"/>
-            <a:ext cx="128016" cy="128016"/>
-          </a:xfrm>
-          <a:prstGeom prst="ellipse">
-            <a:avLst/>
-          </a:prstGeom>
-          <a:solidFill>
-            <a:srgbClr val="5CC98A"/>
-          </a:solidFill>
-          <a:ln>
-            <a:noFill/>
-          </a:ln>
-          <a:effectLst/>
-        </p:spPr>
-        <p:style>
-          <a:lnRef idx="1">
-            <a:schemeClr val="accent1"/>
-          </a:lnRef>
-          <a:fillRef idx="3">
-            <a:schemeClr val="accent1"/>
-          </a:fillRef>
-          <a:effectRef idx="2">
-            <a:schemeClr val="accent1"/>
-          </a:effectRef>
-          <a:fontRef idx="minor">
-            <a:schemeClr val="lt1"/>
-          </a:fontRef>
-        </p:style>
-        <p:txBody>
-          <a:bodyPr rtlCol="0" anchor="ctr"/>
-          <a:lstStyle/>
-          <a:p>
-            <a:pPr algn="ctr"/>
-          </a:p>
-        </p:txBody>
-      </p:sp>
-      <p:sp>
-        <p:nvSpPr>
-          <p:cNvPr id="49" name="TextBox 48"/>
-          <p:cNvSpPr txBox="1"/>
-          <p:nvPr/>
-        </p:nvSpPr>
-        <p:spPr>
-          <a:xfrm>
-            <a:off x="548640" y="5989320"/>
-            <a:ext cx="5852160" cy="274320"/>
+            <a:off x="7908988" y="3611879"/>
+            <a:ext cx="2771775" cy="365760"/>
           </a:xfrm>
           <a:prstGeom prst="rect">
             <a:avLst/>
@@ -14643,6 +13537,87 @@
           </a:bodyPr>
           <a:lstStyle/>
           <a:p>
+            <a:pPr algn="ctr">
+              <a:spcAft>
+                <a:spcPts val="0"/>
+              </a:spcAft>
+            </a:pPr>
+            <a:r>
+              <a:rPr sz="1400" b="1">
+                <a:solidFill>
+                  <a:srgbClr val="ECEEF1"/>
+                </a:solidFill>
+                <a:latin typeface="Arial"/>
+              </a:rPr>
+              <a:t>Telegram demo video</a:t>
+            </a:r>
+          </a:p>
+        </p:txBody>
+      </p:sp>
+      <p:sp>
+        <p:nvSpPr>
+          <p:cNvPr id="25" name="TextBox 24"/>
+          <p:cNvSpPr txBox="1"/>
+          <p:nvPr/>
+        </p:nvSpPr>
+        <p:spPr>
+          <a:xfrm>
+            <a:off x="7908988" y="3977639"/>
+            <a:ext cx="2771775" cy="731520"/>
+          </a:xfrm>
+          <a:prstGeom prst="rect">
+            <a:avLst/>
+          </a:prstGeom>
+          <a:noFill/>
+        </p:spPr>
+        <p:txBody>
+          <a:bodyPr wrap="square" lIns="0" rIns="0" tIns="0" bIns="0" anchor="t">
+            <a:spAutoFit/>
+          </a:bodyPr>
+          <a:lstStyle/>
+          <a:p>
+            <a:pPr algn="ctr">
+              <a:lnSpc>
+                <a:spcPct val="110000"/>
+              </a:lnSpc>
+              <a:spcAft>
+                <a:spcPts val="0"/>
+              </a:spcAft>
+            </a:pPr>
+            <a:r>
+              <a:rPr sz="1050" b="0">
+                <a:solidFill>
+                  <a:srgbClr val="A9B0B9"/>
+                </a:solidFill>
+                <a:latin typeface="Arial"/>
+              </a:rPr>
+              <a:t>Insert → Video, then fit it to this 9:16 frame</a:t>
+            </a:r>
+          </a:p>
+        </p:txBody>
+      </p:sp>
+      <p:sp>
+        <p:nvSpPr>
+          <p:cNvPr id="26" name="TextBox 25"/>
+          <p:cNvSpPr txBox="1"/>
+          <p:nvPr/>
+        </p:nvSpPr>
+        <p:spPr>
+          <a:xfrm>
+            <a:off x="548640" y="5989320"/>
+            <a:ext cx="5852160" cy="274320"/>
+          </a:xfrm>
+          <a:prstGeom prst="rect">
+            <a:avLst/>
+          </a:prstGeom>
+          <a:noFill/>
+        </p:spPr>
+        <p:txBody>
+          <a:bodyPr wrap="square" lIns="0" rIns="0" tIns="0" bIns="0" anchor="t">
+            <a:spAutoFit/>
+          </a:bodyPr>
+          <a:lstStyle/>
+          <a:p>
             <a:pPr algn="l">
               <a:spcAft>
                 <a:spcPts val="0"/>
@@ -14655,14 +13630,14 @@
                 </a:solidFill>
                 <a:latin typeface="Arial"/>
               </a:rPr>
-              <a:t>Working prototype on the same database as the web app. Messages translated from Romanian.</a:t>
-            </a:r>
-          </a:p>
-        </p:txBody>
-      </p:sp>
-      <p:sp>
-        <p:nvSpPr>
-          <p:cNvPr id="50" name="Rounded Rectangle 49"/>
+              <a:t>Live on the same database as the web app. The bot replies in Romanian.</a:t>
+            </a:r>
+          </a:p>
+        </p:txBody>
+      </p:sp>
+      <p:sp>
+        <p:nvSpPr>
+          <p:cNvPr id="27" name="Rounded Rectangle 26"/>
           <p:cNvSpPr/>
           <p:nvPr/>
         </p:nvSpPr>
@@ -14708,7 +13683,7 @@
       </p:sp>
       <p:sp>
         <p:nvSpPr>
-          <p:cNvPr id="51" name="Rounded Rectangle 50"/>
+          <p:cNvPr id="28" name="Rounded Rectangle 27"/>
           <p:cNvSpPr/>
           <p:nvPr/>
         </p:nvSpPr>
@@ -14754,7 +13729,7 @@
       </p:sp>
       <p:sp>
         <p:nvSpPr>
-          <p:cNvPr id="52" name="Rounded Rectangle 51"/>
+          <p:cNvPr id="29" name="Rounded Rectangle 28"/>
           <p:cNvSpPr/>
           <p:nvPr/>
         </p:nvSpPr>
@@ -14800,7 +13775,7 @@
       </p:sp>
       <p:cxnSp>
         <p:nvCxnSpPr>
-          <p:cNvPr id="53" name="Connector 52"/>
+          <p:cNvPr id="30" name="Connector 29"/>
           <p:cNvCxnSpPr/>
           <p:nvPr/>
         </p:nvCxnSpPr>
@@ -14835,7 +13810,7 @@
       </p:cxnSp>
       <p:sp>
         <p:nvSpPr>
-          <p:cNvPr id="54" name="TextBox 53"/>
+          <p:cNvPr id="31" name="TextBox 30"/>
           <p:cNvSpPr txBox="1"/>
           <p:nvPr/>
         </p:nvSpPr>
@@ -16449,7 +15424,7 @@
                 <a:gridCol w="3931920"/>
                 <a:gridCol w="4325112"/>
               </a:tblGrid>
-              <a:tr h="438912">
+              <a:tr h="399010">
                 <a:tc>
                   <a:txBody>
                     <a:bodyPr/>
@@ -16517,7 +15492,7 @@
                   </a:tcPr>
                 </a:tc>
               </a:tr>
-              <a:tr h="438912">
+              <a:tr h="399010">
                 <a:tc>
                   <a:txBody>
                     <a:bodyPr/>
@@ -16585,7 +15560,7 @@
                   </a:tcPr>
                 </a:tc>
               </a:tr>
-              <a:tr h="438912">
+              <a:tr h="399010">
                 <a:tc>
                   <a:txBody>
                     <a:bodyPr/>
@@ -16653,7 +15628,7 @@
                   </a:tcPr>
                 </a:tc>
               </a:tr>
-              <a:tr h="438912">
+              <a:tr h="399010">
                 <a:tc>
                   <a:txBody>
                     <a:bodyPr/>
@@ -16721,7 +15696,7 @@
                   </a:tcPr>
                 </a:tc>
               </a:tr>
-              <a:tr h="438912">
+              <a:tr h="399010">
                 <a:tc>
                   <a:txBody>
                     <a:bodyPr/>
@@ -16789,7 +15764,7 @@
                   </a:tcPr>
                 </a:tc>
               </a:tr>
-              <a:tr h="438912">
+              <a:tr h="399010">
                 <a:tc>
                   <a:txBody>
                     <a:bodyPr/>
@@ -16857,7 +15832,7 @@
                   </a:tcPr>
                 </a:tc>
               </a:tr>
-              <a:tr h="438912">
+              <a:tr h="399010">
                 <a:tc>
                   <a:txBody>
                     <a:bodyPr/>
@@ -16925,7 +15900,7 @@
                   </a:tcPr>
                 </a:tc>
               </a:tr>
-              <a:tr h="438912">
+              <a:tr h="399010">
                 <a:tc>
                   <a:txBody>
                     <a:bodyPr/>
@@ -16938,7 +15913,7 @@
                           </a:solidFill>
                           <a:latin typeface="Arial"/>
                         </a:rPr>
-                        <a:t>Duplicate check</a:t>
+                        <a:t>Credibility</a:t>
                       </a:r>
                     </a:p>
                   </a:txBody>
@@ -16960,7 +15935,7 @@
                           </a:solidFill>
                           <a:latin typeface="Arial"/>
                         </a:rPr>
-                        <a:t>Similar reports within 300 m</a:t>
+                        <a:t>Start 50 · "Me too" +1 · "Mine works" −0.5</a:t>
                       </a:r>
                     </a:p>
                   </a:txBody>
@@ -16982,7 +15957,7 @@
                           </a:solidFill>
                           <a:latin typeface="Arial"/>
                         </a:rPr>
-                        <a:t>One problem → one report with more confirmations</a:t>
+                        <a:t>Below 40: no reports for 7 days (account and device), then back to 50</a:t>
                       </a:r>
                     </a:p>
                   </a:txBody>
@@ -16993,7 +15968,7 @@
                   </a:tcPr>
                 </a:tc>
               </a:tr>
-              <a:tr h="438912">
+              <a:tr h="399010">
                 <a:tc>
                   <a:txBody>
                     <a:bodyPr/>
@@ -17006,7 +15981,7 @@
                           </a:solidFill>
                           <a:latin typeface="Arial"/>
                         </a:rPr>
-                        <a:t>Expiry</a:t>
+                        <a:t>Duplicate check</a:t>
                       </a:r>
                     </a:p>
                   </a:txBody>
@@ -17028,7 +16003,7 @@
                           </a:solidFill>
                           <a:latin typeface="Arial"/>
                         </a:rPr>
-                        <a:t>6 h unconfirmed · 24 h with no activity</a:t>
+                        <a:t>Similar reports within 300 m</a:t>
                       </a:r>
                     </a:p>
                   </a:txBody>
@@ -17050,7 +16025,7 @@
                           </a:solidFill>
                           <a:latin typeface="Arial"/>
                         </a:rPr>
-                        <a:t>The map shows the present, not old news</a:t>
+                        <a:t>One problem → one report with more confirmations</a:t>
                       </a:r>
                     </a:p>
                   </a:txBody>
@@ -17061,7 +16036,7 @@
                   </a:tcPr>
                 </a:tc>
               </a:tr>
-              <a:tr h="438912">
+              <a:tr h="399010">
                 <a:tc>
                   <a:txBody>
                     <a:bodyPr/>
@@ -17074,7 +16049,7 @@
                           </a:solidFill>
                           <a:latin typeface="Arial"/>
                         </a:rPr>
-                        <a:t>Affected address</a:t>
+                        <a:t>Expiry</a:t>
                       </a:r>
                     </a:p>
                   </a:txBody>
@@ -17096,7 +16071,7 @@
                           </a:solidFill>
                           <a:latin typeface="Arial"/>
                         </a:rPr>
-                        <a:t>Saved address within 250 m</a:t>
+                        <a:t>6 h unconfirmed · 24 h with no activity</a:t>
                       </a:r>
                     </a:p>
                   </a:txBody>
@@ -17118,13 +16093,81 @@
                           </a:solidFill>
                           <a:latin typeface="Arial"/>
                         </a:rPr>
+                        <a:t>The map shows the present, not old news</a:t>
+                      </a:r>
+                    </a:p>
+                  </a:txBody>
+                  <a:tcPr marL="137160" marT="36576" marB="36576" anchor="ctr">
+                    <a:solidFill>
+                      <a:srgbClr val="F3F3EF"/>
+                    </a:solidFill>
+                  </a:tcPr>
+                </a:tc>
+              </a:tr>
+              <a:tr h="399020">
+                <a:tc>
+                  <a:txBody>
+                    <a:bodyPr/>
+                    <a:lstStyle/>
+                    <a:p>
+                      <a:r>
+                        <a:rPr sz="1150" b="1">
+                          <a:solidFill>
+                            <a:srgbClr val="16181B"/>
+                          </a:solidFill>
+                          <a:latin typeface="Arial"/>
+                        </a:rPr>
+                        <a:t>Affected address</a:t>
+                      </a:r>
+                    </a:p>
+                  </a:txBody>
+                  <a:tcPr marL="137160" marT="36576" marB="36576" anchor="ctr">
+                    <a:solidFill>
+                      <a:srgbClr val="FFFFFF"/>
+                    </a:solidFill>
+                  </a:tcPr>
+                </a:tc>
+                <a:tc>
+                  <a:txBody>
+                    <a:bodyPr/>
+                    <a:lstStyle/>
+                    <a:p>
+                      <a:r>
+                        <a:rPr sz="1150" b="0">
+                          <a:solidFill>
+                            <a:srgbClr val="16181B"/>
+                          </a:solidFill>
+                          <a:latin typeface="Arial"/>
+                        </a:rPr>
+                        <a:t>Saved address within 50 m</a:t>
+                      </a:r>
+                    </a:p>
+                  </a:txBody>
+                  <a:tcPr marL="137160" marT="36576" marB="36576" anchor="ctr">
+                    <a:solidFill>
+                      <a:srgbClr val="FFFFFF"/>
+                    </a:solidFill>
+                  </a:tcPr>
+                </a:tc>
+                <a:tc>
+                  <a:txBody>
+                    <a:bodyPr/>
+                    <a:lstStyle/>
+                    <a:p>
+                      <a:r>
+                        <a:rPr sz="1150" b="0">
+                          <a:solidFill>
+                            <a:srgbClr val="555A61"/>
+                          </a:solidFill>
+                          <a:latin typeface="Arial"/>
+                        </a:rPr>
                         <a:t>Personal "you're affected" signal</a:t>
                       </a:r>
                     </a:p>
                   </a:txBody>
                   <a:tcPr marL="137160" marT="36576" marB="36576" anchor="ctr">
                     <a:solidFill>
-                      <a:srgbClr val="F3F3EF"/>
+                      <a:srgbClr val="FFFFFF"/>
                     </a:solidFill>
                   </a:tcPr>
                 </a:tc>
@@ -20400,7 +19443,7 @@
                 </a:solidFill>
                 <a:latin typeface="Arial"/>
               </a:rPr>
-              <a:t>4 providers imported every hour, placed on the real streets</a:t>
+              <a:t>4 providers imported every 1–2 hours, placed on the real streets</a:t>
             </a:r>
           </a:p>
         </p:txBody>
@@ -20973,7 +20016,7 @@
                 </a:solidFill>
                 <a:latin typeface="Arial"/>
               </a:rPr>
-              <a:t>40</a:t>
+              <a:t>42</a:t>
             </a:r>
           </a:p>
         </p:txBody>
@@ -21102,7 +20145,7 @@
                 </a:solidFill>
                 <a:latin typeface="Arial"/>
               </a:rPr>
-              <a:t>544</a:t>
+              <a:t>546</a:t>
             </a:r>
           </a:p>
         </p:txBody>
@@ -25426,7 +24469,7 @@
                 </a:solidFill>
                 <a:latin typeface="Arial"/>
               </a:rPr>
-              <a:t>Telegram bot prototype: link your account, report a problem</a:t>
+              <a:t>Telegram bot: link your account, report a problem</a:t>
             </a:r>
           </a:p>
           <a:p>
@@ -26227,7 +25270,7 @@
                 </a:solidFill>
                 <a:latin typeface="Arial"/>
               </a:rPr>
-              <a:t>≤ 1 h</a:t>
+              <a:t>≤ 2 h</a:t>
             </a:r>
           </a:p>
         </p:txBody>
@@ -26609,7 +25652,7 @@
                 </a:solidFill>
                 <a:latin typeface="Arial"/>
               </a:rPr>
-              <a:t>How we estimated: 4 = the official sources we import · 1 h = our import schedule · 720K = 2024 census, Chișinău municipality · demand: 91% of the people we surveyed want this in one place, 83% would use it.</a:t>
+              <a:t>How we estimated: 4 = the official sources we import · 2 h = our slowest import (gas; water and power every hour) · 720K = 2024 census, Chișinău municipality · demand: 91% of the people we surveyed want this in one place, 83% would use it.</a:t>
             </a:r>
           </a:p>
         </p:txBody>

</xml_diff>